<commit_message>
Presentation of the third tutorial
</commit_message>
<xml_diff>
--- a/S4P_School_2026/Presentation_DRAGON.pptx
+++ b/S4P_School_2026/Presentation_DRAGON.pptx
@@ -114,6 +114,11 @@
       </a:defRPr>
     </a:lvl9pPr>
   </p:defaultTextStyle>
+  <p:extLst>
+    <p:ext uri="{EFAFB233-063F-42B5-8137-9DF3F51BA10A}">
+      <p15:sldGuideLst xmlns:p15="http://schemas.microsoft.com/office/powerpoint/2012/main"/>
+    </p:ext>
+  </p:extLst>
 </p:presentation>
 </file>
 
@@ -995,7 +1000,7 @@
           <a:p>
             <a:fld id="{CE28A001-7CE3-4455-8863-08D16E29AACA}" type="datetimeFigureOut">
               <a:rPr lang="en-GB" smtClean="0"/>
-              <a:t>12/03/2026</a:t>
+              <a:t>16/03/2026</a:t>
             </a:fld>
             <a:endParaRPr lang="en-GB"/>
           </a:p>
@@ -2007,7 +2012,7 @@
           <a:p>
             <a:fld id="{F9BB38CF-8D7F-428D-B7AF-819739570A87}" type="datetimeFigureOut">
               <a:rPr lang="en-GB" smtClean="0"/>
-              <a:t>12/03/2026</a:t>
+              <a:t>16/03/2026</a:t>
             </a:fld>
             <a:endParaRPr lang="en-GB"/>
           </a:p>
@@ -2207,7 +2212,7 @@
           <a:p>
             <a:fld id="{F9BB38CF-8D7F-428D-B7AF-819739570A87}" type="datetimeFigureOut">
               <a:rPr lang="en-GB" smtClean="0"/>
-              <a:t>12/03/2026</a:t>
+              <a:t>16/03/2026</a:t>
             </a:fld>
             <a:endParaRPr lang="en-GB"/>
           </a:p>
@@ -2417,7 +2422,7 @@
           <a:p>
             <a:fld id="{F9BB38CF-8D7F-428D-B7AF-819739570A87}" type="datetimeFigureOut">
               <a:rPr lang="en-GB" smtClean="0"/>
-              <a:t>12/03/2026</a:t>
+              <a:t>16/03/2026</a:t>
             </a:fld>
             <a:endParaRPr lang="en-GB"/>
           </a:p>
@@ -2617,7 +2622,7 @@
           <a:p>
             <a:fld id="{F9BB38CF-8D7F-428D-B7AF-819739570A87}" type="datetimeFigureOut">
               <a:rPr lang="en-GB" smtClean="0"/>
-              <a:t>12/03/2026</a:t>
+              <a:t>16/03/2026</a:t>
             </a:fld>
             <a:endParaRPr lang="en-GB"/>
           </a:p>
@@ -2893,7 +2898,7 @@
           <a:p>
             <a:fld id="{F9BB38CF-8D7F-428D-B7AF-819739570A87}" type="datetimeFigureOut">
               <a:rPr lang="en-GB" smtClean="0"/>
-              <a:t>12/03/2026</a:t>
+              <a:t>16/03/2026</a:t>
             </a:fld>
             <a:endParaRPr lang="en-GB"/>
           </a:p>
@@ -3161,7 +3166,7 @@
           <a:p>
             <a:fld id="{F9BB38CF-8D7F-428D-B7AF-819739570A87}" type="datetimeFigureOut">
               <a:rPr lang="en-GB" smtClean="0"/>
-              <a:t>12/03/2026</a:t>
+              <a:t>16/03/2026</a:t>
             </a:fld>
             <a:endParaRPr lang="en-GB"/>
           </a:p>
@@ -3576,7 +3581,7 @@
           <a:p>
             <a:fld id="{F9BB38CF-8D7F-428D-B7AF-819739570A87}" type="datetimeFigureOut">
               <a:rPr lang="en-GB" smtClean="0"/>
-              <a:t>12/03/2026</a:t>
+              <a:t>16/03/2026</a:t>
             </a:fld>
             <a:endParaRPr lang="en-GB"/>
           </a:p>
@@ -3718,7 +3723,7 @@
           <a:p>
             <a:fld id="{F9BB38CF-8D7F-428D-B7AF-819739570A87}" type="datetimeFigureOut">
               <a:rPr lang="en-GB" smtClean="0"/>
-              <a:t>12/03/2026</a:t>
+              <a:t>16/03/2026</a:t>
             </a:fld>
             <a:endParaRPr lang="en-GB"/>
           </a:p>
@@ -3831,7 +3836,7 @@
           <a:p>
             <a:fld id="{F9BB38CF-8D7F-428D-B7AF-819739570A87}" type="datetimeFigureOut">
               <a:rPr lang="en-GB" smtClean="0"/>
-              <a:t>12/03/2026</a:t>
+              <a:t>16/03/2026</a:t>
             </a:fld>
             <a:endParaRPr lang="en-GB"/>
           </a:p>
@@ -4144,7 +4149,7 @@
           <a:p>
             <a:fld id="{F9BB38CF-8D7F-428D-B7AF-819739570A87}" type="datetimeFigureOut">
               <a:rPr lang="en-GB" smtClean="0"/>
-              <a:t>12/03/2026</a:t>
+              <a:t>16/03/2026</a:t>
             </a:fld>
             <a:endParaRPr lang="en-GB"/>
           </a:p>
@@ -4433,7 +4438,7 @@
           <a:p>
             <a:fld id="{F9BB38CF-8D7F-428D-B7AF-819739570A87}" type="datetimeFigureOut">
               <a:rPr lang="en-GB" smtClean="0"/>
-              <a:t>12/03/2026</a:t>
+              <a:t>16/03/2026</a:t>
             </a:fld>
             <a:endParaRPr lang="en-GB"/>
           </a:p>
@@ -4676,7 +4681,7 @@
           <a:p>
             <a:fld id="{F9BB38CF-8D7F-428D-B7AF-819739570A87}" type="datetimeFigureOut">
               <a:rPr lang="en-GB" smtClean="0"/>
-              <a:t>12/03/2026</a:t>
+              <a:t>16/03/2026</a:t>
             </a:fld>
             <a:endParaRPr lang="en-GB"/>
           </a:p>
@@ -5095,6 +5100,63 @@
       </p:grpSpPr>
       <p:sp>
         <p:nvSpPr>
+          <p:cNvPr id="4" name="Rectangle 3">
+            <a:extLst>
+              <a:ext uri="{FF2B5EF4-FFF2-40B4-BE49-F238E27FC236}">
+                <a16:creationId xmlns:a16="http://schemas.microsoft.com/office/drawing/2014/main" id="{055D232C-AD2B-46B3-B0AA-BB1E9196090B}"/>
+              </a:ext>
+            </a:extLst>
+          </p:cNvPr>
+          <p:cNvSpPr/>
+          <p:nvPr/>
+        </p:nvSpPr>
+        <p:spPr>
+          <a:xfrm>
+            <a:off x="0" y="0"/>
+            <a:ext cx="12192000" cy="6858000"/>
+          </a:xfrm>
+          <a:prstGeom prst="rect">
+            <a:avLst/>
+          </a:prstGeom>
+          <a:blipFill>
+            <a:blip r:embed="rId3">
+              <a:alphaModFix amt="20000"/>
+            </a:blip>
+            <a:tile tx="0" ty="0" sx="100000" sy="100000" flip="none" algn="tl"/>
+          </a:blipFill>
+          <a:ln>
+            <a:solidFill>
+              <a:schemeClr val="bg1"/>
+            </a:solidFill>
+          </a:ln>
+        </p:spPr>
+        <p:style>
+          <a:lnRef idx="2">
+            <a:schemeClr val="accent1">
+              <a:shade val="50000"/>
+            </a:schemeClr>
+          </a:lnRef>
+          <a:fillRef idx="1">
+            <a:schemeClr val="accent1"/>
+          </a:fillRef>
+          <a:effectRef idx="0">
+            <a:schemeClr val="accent1"/>
+          </a:effectRef>
+          <a:fontRef idx="minor">
+            <a:schemeClr val="lt1"/>
+          </a:fontRef>
+        </p:style>
+        <p:txBody>
+          <a:bodyPr rtlCol="0" anchor="ctr"/>
+          <a:lstStyle/>
+          <a:p>
+            <a:pPr algn="ctr"/>
+            <a:endParaRPr lang="en-SE" dirty="0"/>
+          </a:p>
+        </p:txBody>
+      </p:sp>
+      <p:sp>
+        <p:nvSpPr>
           <p:cNvPr id="2" name="Title 1">
             <a:extLst>
               <a:ext uri="{FF2B5EF4-FFF2-40B4-BE49-F238E27FC236}">
@@ -5136,7 +5198,7 @@
                   </a:outerShdw>
                 </a:effectLst>
               </a:rPr>
-              <a:t>ANTINUCLEI IN THE UNIVERSE? - MIAPP 2022</a:t>
+              <a:t>Palestinian Advanced School - 2026</a:t>
             </a:r>
           </a:p>
         </p:txBody>
@@ -5244,7 +5306,7 @@
           <p:nvPr/>
         </p:nvPicPr>
         <p:blipFill>
-          <a:blip r:embed="rId3">
+          <a:blip r:embed="rId4">
             <a:extLst>
               <a:ext uri="{28A0092B-C50C-407E-A947-70E740481C1C}">
                 <a14:useLocalDpi xmlns:a14="http://schemas.microsoft.com/office/drawing/2010/main" val="0"/>
@@ -5308,20 +5370,6 @@
               </a:rPr>
               <a:t>Pedro de la Torre Luque </a:t>
             </a:r>
-            <a:r>
-              <a:rPr lang="it-IT" kern="150" dirty="0">
-                <a:solidFill>
-                  <a:schemeClr val="bg2">
-                    <a:lumMod val="25000"/>
-                  </a:schemeClr>
-                </a:solidFill>
-                <a:effectLst/>
-                <a:latin typeface="Times New Roman" panose="02020603050405020304" pitchFamily="18" charset="0"/>
-                <a:ea typeface="SimSun" panose="02010600030101010101" pitchFamily="2" charset="-122"/>
-                <a:cs typeface="Mangal" panose="02040503050203030202" pitchFamily="18" charset="0"/>
-              </a:rPr>
-              <a:t>- on behalf of the DRAGON team</a:t>
-            </a:r>
           </a:p>
           <a:p>
             <a:pPr algn="just"/>
@@ -5336,7 +5384,7 @@
                 <a:ea typeface="SimSun" panose="02010600030101010101" pitchFamily="2" charset="-122"/>
                 <a:cs typeface="Mangal" panose="02040503050203030202" pitchFamily="18" charset="0"/>
               </a:rPr>
-              <a:t>pedro.delatorreluque@fysik.su.se</a:t>
+              <a:t>pedro.delatorre@uam.es</a:t>
             </a:r>
             <a:endParaRPr lang="en-GB" kern="150" dirty="0">
               <a:solidFill>
@@ -5352,63 +5400,83 @@
           </a:p>
         </p:txBody>
       </p:sp>
-      <p:sp>
-        <p:nvSpPr>
-          <p:cNvPr id="4" name="Rectangle 3">
+      <p:pic>
+        <p:nvPicPr>
+          <p:cNvPr id="5" name="Picture 2">
             <a:extLst>
               <a:ext uri="{FF2B5EF4-FFF2-40B4-BE49-F238E27FC236}">
-                <a16:creationId xmlns:a16="http://schemas.microsoft.com/office/drawing/2014/main" id="{055D232C-AD2B-46B3-B0AA-BB1E9196090B}"/>
+                <a16:creationId xmlns:a16="http://schemas.microsoft.com/office/drawing/2014/main" id="{2199A0CE-08AC-23EE-858A-D9777223946D}"/>
               </a:ext>
             </a:extLst>
           </p:cNvPr>
-          <p:cNvSpPr/>
+          <p:cNvPicPr>
+            <a:picLocks noChangeAspect="1" noChangeArrowheads="1"/>
+          </p:cNvPicPr>
           <p:nvPr/>
-        </p:nvSpPr>
-        <p:spPr>
+        </p:nvPicPr>
+        <p:blipFill>
+          <a:blip r:embed="rId5">
+            <a:extLst>
+              <a:ext uri="{28A0092B-C50C-407E-A947-70E740481C1C}">
+                <a14:useLocalDpi xmlns:a14="http://schemas.microsoft.com/office/drawing/2010/main" val="0"/>
+              </a:ext>
+            </a:extLst>
+          </a:blip>
+          <a:srcRect/>
+          <a:stretch>
+            <a:fillRect/>
+          </a:stretch>
+        </p:blipFill>
+        <p:spPr bwMode="auto">
           <a:xfrm>
-            <a:off x="0" y="0"/>
-            <a:ext cx="12192000" cy="6858000"/>
+            <a:off x="0" y="6167"/>
+            <a:ext cx="4161336" cy="804633"/>
           </a:xfrm>
           <a:prstGeom prst="rect">
             <a:avLst/>
           </a:prstGeom>
-          <a:blipFill>
-            <a:blip r:embed="rId4">
-              <a:alphaModFix amt="20000"/>
-            </a:blip>
-            <a:tile tx="0" ty="0" sx="100000" sy="100000" flip="none" algn="tl"/>
-          </a:blipFill>
-          <a:ln>
-            <a:solidFill>
-              <a:schemeClr val="bg1"/>
-            </a:solidFill>
-          </a:ln>
+          <a:noFill/>
+          <a:extLst>
+            <a:ext uri="{909E8E84-426E-40DD-AFC4-6F175D3DCCD1}">
+              <a14:hiddenFill xmlns:a14="http://schemas.microsoft.com/office/drawing/2010/main">
+                <a:solidFill>
+                  <a:srgbClr val="FFFFFF"/>
+                </a:solidFill>
+              </a14:hiddenFill>
+            </a:ext>
+          </a:extLst>
         </p:spPr>
-        <p:style>
-          <a:lnRef idx="2">
-            <a:schemeClr val="accent1">
-              <a:shade val="50000"/>
-            </a:schemeClr>
-          </a:lnRef>
-          <a:fillRef idx="1">
-            <a:schemeClr val="accent1"/>
-          </a:fillRef>
-          <a:effectRef idx="0">
-            <a:schemeClr val="accent1"/>
-          </a:effectRef>
-          <a:fontRef idx="minor">
-            <a:schemeClr val="lt1"/>
-          </a:fontRef>
-        </p:style>
-        <p:txBody>
-          <a:bodyPr rtlCol="0" anchor="ctr"/>
-          <a:lstStyle/>
-          <a:p>
-            <a:pPr algn="ctr"/>
-            <a:endParaRPr lang="en-SE" dirty="0"/>
-          </a:p>
-        </p:txBody>
-      </p:sp>
+      </p:pic>
+      <p:pic>
+        <p:nvPicPr>
+          <p:cNvPr id="6" name="Picture 5">
+            <a:extLst>
+              <a:ext uri="{FF2B5EF4-FFF2-40B4-BE49-F238E27FC236}">
+                <a16:creationId xmlns:a16="http://schemas.microsoft.com/office/drawing/2014/main" id="{649C66A8-1481-BCA2-E627-07C10D827414}"/>
+              </a:ext>
+            </a:extLst>
+          </p:cNvPr>
+          <p:cNvPicPr>
+            <a:picLocks noChangeAspect="1"/>
+          </p:cNvPicPr>
+          <p:nvPr/>
+        </p:nvPicPr>
+        <p:blipFill>
+          <a:blip r:embed="rId6"/>
+          <a:stretch>
+            <a:fillRect/>
+          </a:stretch>
+        </p:blipFill>
+        <p:spPr>
+          <a:xfrm>
+            <a:off x="10791780" y="41834"/>
+            <a:ext cx="1400220" cy="804633"/>
+          </a:xfrm>
+          <a:prstGeom prst="rect">
+            <a:avLst/>
+          </a:prstGeom>
+        </p:spPr>
+      </p:pic>
     </p:spTree>
     <p:extLst>
       <p:ext uri="{BB962C8B-B14F-4D97-AF65-F5344CB8AC3E}">

</xml_diff>